<commit_message>
feat: glm-hmm summary fixed
</commit_message>
<xml_diff>
--- a/dissemination/glm_hmm_draft.pptx
+++ b/dissemination/glm_hmm_draft.pptx
@@ -108,6 +108,11 @@
       </a:defRPr>
     </a:lvl9pPr>
   </p:defaultTextStyle>
+  <p:extLst>
+    <p:ext uri="{EFAFB233-063F-42B5-8137-9DF3F51BA10A}">
+      <p15:sldGuideLst xmlns:p15="http://schemas.microsoft.com/office/powerpoint/2012/main"/>
+    </p:ext>
+  </p:extLst>
 </p:presentation>
 </file>
 
@@ -258,7 +263,7 @@
           <a:p>
             <a:fld id="{10F3CF75-C5FC-4F65-800B-D543082CDC76}" type="datetimeFigureOut">
               <a:rPr lang="en-US" smtClean="0"/>
-              <a:t>7/2/2025</a:t>
+              <a:t>7/8/2025</a:t>
             </a:fld>
             <a:endParaRPr lang="en-US"/>
           </a:p>
@@ -456,7 +461,7 @@
           <a:p>
             <a:fld id="{10F3CF75-C5FC-4F65-800B-D543082CDC76}" type="datetimeFigureOut">
               <a:rPr lang="en-US" smtClean="0"/>
-              <a:t>7/2/2025</a:t>
+              <a:t>7/8/2025</a:t>
             </a:fld>
             <a:endParaRPr lang="en-US"/>
           </a:p>
@@ -664,7 +669,7 @@
           <a:p>
             <a:fld id="{10F3CF75-C5FC-4F65-800B-D543082CDC76}" type="datetimeFigureOut">
               <a:rPr lang="en-US" smtClean="0"/>
-              <a:t>7/2/2025</a:t>
+              <a:t>7/8/2025</a:t>
             </a:fld>
             <a:endParaRPr lang="en-US"/>
           </a:p>
@@ -862,7 +867,7 @@
           <a:p>
             <a:fld id="{10F3CF75-C5FC-4F65-800B-D543082CDC76}" type="datetimeFigureOut">
               <a:rPr lang="en-US" smtClean="0"/>
-              <a:t>7/2/2025</a:t>
+              <a:t>7/8/2025</a:t>
             </a:fld>
             <a:endParaRPr lang="en-US"/>
           </a:p>
@@ -1137,7 +1142,7 @@
           <a:p>
             <a:fld id="{10F3CF75-C5FC-4F65-800B-D543082CDC76}" type="datetimeFigureOut">
               <a:rPr lang="en-US" smtClean="0"/>
-              <a:t>7/2/2025</a:t>
+              <a:t>7/8/2025</a:t>
             </a:fld>
             <a:endParaRPr lang="en-US"/>
           </a:p>
@@ -1402,7 +1407,7 @@
           <a:p>
             <a:fld id="{10F3CF75-C5FC-4F65-800B-D543082CDC76}" type="datetimeFigureOut">
               <a:rPr lang="en-US" smtClean="0"/>
-              <a:t>7/2/2025</a:t>
+              <a:t>7/8/2025</a:t>
             </a:fld>
             <a:endParaRPr lang="en-US"/>
           </a:p>
@@ -1814,7 +1819,7 @@
           <a:p>
             <a:fld id="{10F3CF75-C5FC-4F65-800B-D543082CDC76}" type="datetimeFigureOut">
               <a:rPr lang="en-US" smtClean="0"/>
-              <a:t>7/2/2025</a:t>
+              <a:t>7/8/2025</a:t>
             </a:fld>
             <a:endParaRPr lang="en-US"/>
           </a:p>
@@ -1955,7 +1960,7 @@
           <a:p>
             <a:fld id="{10F3CF75-C5FC-4F65-800B-D543082CDC76}" type="datetimeFigureOut">
               <a:rPr lang="en-US" smtClean="0"/>
-              <a:t>7/2/2025</a:t>
+              <a:t>7/8/2025</a:t>
             </a:fld>
             <a:endParaRPr lang="en-US"/>
           </a:p>
@@ -2068,7 +2073,7 @@
           <a:p>
             <a:fld id="{10F3CF75-C5FC-4F65-800B-D543082CDC76}" type="datetimeFigureOut">
               <a:rPr lang="en-US" smtClean="0"/>
-              <a:t>7/2/2025</a:t>
+              <a:t>7/8/2025</a:t>
             </a:fld>
             <a:endParaRPr lang="en-US"/>
           </a:p>
@@ -2379,7 +2384,7 @@
           <a:p>
             <a:fld id="{10F3CF75-C5FC-4F65-800B-D543082CDC76}" type="datetimeFigureOut">
               <a:rPr lang="en-US" smtClean="0"/>
-              <a:t>7/2/2025</a:t>
+              <a:t>7/8/2025</a:t>
             </a:fld>
             <a:endParaRPr lang="en-US"/>
           </a:p>
@@ -2667,7 +2672,7 @@
           <a:p>
             <a:fld id="{10F3CF75-C5FC-4F65-800B-D543082CDC76}" type="datetimeFigureOut">
               <a:rPr lang="en-US" smtClean="0"/>
-              <a:t>7/2/2025</a:t>
+              <a:t>7/8/2025</a:t>
             </a:fld>
             <a:endParaRPr lang="en-US"/>
           </a:p>
@@ -2908,7 +2913,7 @@
           <a:p>
             <a:fld id="{10F3CF75-C5FC-4F65-800B-D543082CDC76}" type="datetimeFigureOut">
               <a:rPr lang="en-US" smtClean="0"/>
-              <a:t>7/2/2025</a:t>
+              <a:t>7/8/2025</a:t>
             </a:fld>
             <a:endParaRPr lang="en-US"/>
           </a:p>
@@ -3438,8 +3443,8 @@
         </p:blipFill>
         <p:spPr>
           <a:xfrm>
-            <a:off x="2978600" y="949111"/>
-            <a:ext cx="5789568" cy="4541562"/>
+            <a:off x="3128703" y="1158219"/>
+            <a:ext cx="5624113" cy="4541562"/>
           </a:xfrm>
           <a:prstGeom prst="rect">
             <a:avLst/>
@@ -3503,8 +3508,8 @@
         </p:blipFill>
         <p:spPr>
           <a:xfrm>
-            <a:off x="1978645" y="1110448"/>
-            <a:ext cx="7683736" cy="4724400"/>
+            <a:off x="1978645" y="1220614"/>
+            <a:ext cx="7683736" cy="4504066"/>
           </a:xfrm>
           <a:prstGeom prst="rect">
             <a:avLst/>
@@ -3568,8 +3573,8 @@
         </p:blipFill>
         <p:spPr>
           <a:xfrm>
-            <a:off x="2376486" y="1562463"/>
-            <a:ext cx="6139399" cy="4158947"/>
+            <a:off x="2402075" y="1125330"/>
+            <a:ext cx="6780425" cy="4846337"/>
           </a:xfrm>
           <a:prstGeom prst="rect">
             <a:avLst/>
@@ -3633,8 +3638,8 @@
         </p:blipFill>
         <p:spPr>
           <a:xfrm>
-            <a:off x="2816181" y="613383"/>
-            <a:ext cx="6559636" cy="5648325"/>
+            <a:off x="2816181" y="650456"/>
+            <a:ext cx="6559636" cy="5574179"/>
           </a:xfrm>
           <a:prstGeom prst="rect">
             <a:avLst/>

</xml_diff>